<commit_message>
Update Presentations of Bachelor's theses.pptx
</commit_message>
<xml_diff>
--- a/Presentations of Bachelor's theses.pptx
+++ b/Presentations of Bachelor's theses.pptx
@@ -8,6 +8,10 @@
     <p:sldId id="258" r:id="rId2"/>
     <p:sldId id="259" r:id="rId3"/>
     <p:sldId id="257" r:id="rId4"/>
+    <p:sldId id="260" r:id="rId5"/>
+    <p:sldId id="261" r:id="rId6"/>
+    <p:sldId id="262" r:id="rId7"/>
+    <p:sldId id="263" r:id="rId8"/>
   </p:sldIdLst>
   <p:sldSz cx="12192000" cy="6858000"/>
   <p:notesSz cx="6858000" cy="9144000"/>
@@ -106,6 +110,11 @@
       </a:defRPr>
     </a:lvl9pPr>
   </p:defaultTextStyle>
+  <p:extLst>
+    <p:ext uri="{EFAFB233-063F-42B5-8137-9DF3F51BA10A}">
+      <p15:sldGuideLst xmlns:p15="http://schemas.microsoft.com/office/powerpoint/2012/main"/>
+    </p:ext>
+  </p:extLst>
 </p:presentation>
 </file>
 
@@ -258,7 +267,7 @@
           <a:p>
             <a:fld id="{E9846F43-F1B2-4AEE-B1BF-466D06853D46}" type="datetimeFigureOut">
               <a:rPr lang="ru-RU" smtClean="0"/>
-              <a:t>24.11.2025</a:t>
+              <a:t>27.11.2025</a:t>
             </a:fld>
             <a:endParaRPr lang="ru-RU"/>
           </a:p>
@@ -458,7 +467,7 @@
           <a:p>
             <a:fld id="{E9846F43-F1B2-4AEE-B1BF-466D06853D46}" type="datetimeFigureOut">
               <a:rPr lang="ru-RU" smtClean="0"/>
-              <a:t>24.11.2025</a:t>
+              <a:t>27.11.2025</a:t>
             </a:fld>
             <a:endParaRPr lang="ru-RU"/>
           </a:p>
@@ -668,7 +677,7 @@
           <a:p>
             <a:fld id="{E9846F43-F1B2-4AEE-B1BF-466D06853D46}" type="datetimeFigureOut">
               <a:rPr lang="ru-RU" smtClean="0"/>
-              <a:t>24.11.2025</a:t>
+              <a:t>27.11.2025</a:t>
             </a:fld>
             <a:endParaRPr lang="ru-RU"/>
           </a:p>
@@ -868,7 +877,7 @@
           <a:p>
             <a:fld id="{E9846F43-F1B2-4AEE-B1BF-466D06853D46}" type="datetimeFigureOut">
               <a:rPr lang="ru-RU" smtClean="0"/>
-              <a:t>24.11.2025</a:t>
+              <a:t>27.11.2025</a:t>
             </a:fld>
             <a:endParaRPr lang="ru-RU"/>
           </a:p>
@@ -1144,7 +1153,7 @@
           <a:p>
             <a:fld id="{E9846F43-F1B2-4AEE-B1BF-466D06853D46}" type="datetimeFigureOut">
               <a:rPr lang="ru-RU" smtClean="0"/>
-              <a:t>24.11.2025</a:t>
+              <a:t>27.11.2025</a:t>
             </a:fld>
             <a:endParaRPr lang="ru-RU"/>
           </a:p>
@@ -1412,7 +1421,7 @@
           <a:p>
             <a:fld id="{E9846F43-F1B2-4AEE-B1BF-466D06853D46}" type="datetimeFigureOut">
               <a:rPr lang="ru-RU" smtClean="0"/>
-              <a:t>24.11.2025</a:t>
+              <a:t>27.11.2025</a:t>
             </a:fld>
             <a:endParaRPr lang="ru-RU"/>
           </a:p>
@@ -1827,7 +1836,7 @@
           <a:p>
             <a:fld id="{E9846F43-F1B2-4AEE-B1BF-466D06853D46}" type="datetimeFigureOut">
               <a:rPr lang="ru-RU" smtClean="0"/>
-              <a:t>24.11.2025</a:t>
+              <a:t>27.11.2025</a:t>
             </a:fld>
             <a:endParaRPr lang="ru-RU"/>
           </a:p>
@@ -1969,7 +1978,7 @@
           <a:p>
             <a:fld id="{E9846F43-F1B2-4AEE-B1BF-466D06853D46}" type="datetimeFigureOut">
               <a:rPr lang="ru-RU" smtClean="0"/>
-              <a:t>24.11.2025</a:t>
+              <a:t>27.11.2025</a:t>
             </a:fld>
             <a:endParaRPr lang="ru-RU"/>
           </a:p>
@@ -2082,7 +2091,7 @@
           <a:p>
             <a:fld id="{E9846F43-F1B2-4AEE-B1BF-466D06853D46}" type="datetimeFigureOut">
               <a:rPr lang="ru-RU" smtClean="0"/>
-              <a:t>24.11.2025</a:t>
+              <a:t>27.11.2025</a:t>
             </a:fld>
             <a:endParaRPr lang="ru-RU"/>
           </a:p>
@@ -2395,7 +2404,7 @@
           <a:p>
             <a:fld id="{E9846F43-F1B2-4AEE-B1BF-466D06853D46}" type="datetimeFigureOut">
               <a:rPr lang="ru-RU" smtClean="0"/>
-              <a:t>24.11.2025</a:t>
+              <a:t>27.11.2025</a:t>
             </a:fld>
             <a:endParaRPr lang="ru-RU"/>
           </a:p>
@@ -2684,7 +2693,7 @@
           <a:p>
             <a:fld id="{E9846F43-F1B2-4AEE-B1BF-466D06853D46}" type="datetimeFigureOut">
               <a:rPr lang="ru-RU" smtClean="0"/>
-              <a:t>24.11.2025</a:t>
+              <a:t>27.11.2025</a:t>
             </a:fld>
             <a:endParaRPr lang="ru-RU"/>
           </a:p>
@@ -2927,7 +2936,7 @@
           <a:p>
             <a:fld id="{E9846F43-F1B2-4AEE-B1BF-466D06853D46}" type="datetimeFigureOut">
               <a:rPr lang="ru-RU" smtClean="0"/>
-              <a:t>24.11.2025</a:t>
+              <a:t>27.11.2025</a:t>
             </a:fld>
             <a:endParaRPr lang="ru-RU"/>
           </a:p>
@@ -3639,7 +3648,10 @@
           <a:bodyPr/>
           <a:lstStyle/>
           <a:p>
-            <a:endParaRPr lang="ru-RU"/>
+            <a:r>
+              <a:rPr lang="ru-RU" dirty="0"/>
+              <a:t>Актуальность темы</a:t>
+            </a:r>
           </a:p>
         </p:txBody>
       </p:sp>
@@ -3663,6 +3675,30 @@
         <p:txBody>
           <a:bodyPr/>
           <a:lstStyle/>
+          <a:p>
+            <a:r>
+              <a:rPr lang="ru-RU" dirty="0"/>
+              <a:t>Рынок мобильных приложений стремительно растёт по пользователям, загрузкам и выручке.</a:t>
+            </a:r>
+          </a:p>
+          <a:p>
+            <a:r>
+              <a:rPr lang="ru-RU" dirty="0"/>
+              <a:t>Генеративный ИИ усилил спрос на мобильных разработчиков и расширил круг их задач.</a:t>
+            </a:r>
+          </a:p>
+          <a:p>
+            <a:r>
+              <a:rPr lang="ru-RU" dirty="0"/>
+              <a:t>Европа и Северная Америка — одни из самых прибыльных рынков с высокой концентрацией разработчиков и растущей конкуренцией за позиции.</a:t>
+            </a:r>
+          </a:p>
+          <a:p>
+            <a:r>
+              <a:rPr lang="ru-RU" dirty="0"/>
+              <a:t>Быстрая смена технологий (iOS/Android, языки, фреймворки) усложняет выбор актуальных инструментов и обновление учебных программ.</a:t>
+            </a:r>
+          </a:p>
           <a:p>
             <a:endParaRPr lang="ru-RU" dirty="0"/>
           </a:p>
@@ -3719,7 +3755,10 @@
           <a:bodyPr/>
           <a:lstStyle/>
           <a:p>
-            <a:endParaRPr lang="ru-RU"/>
+            <a:r>
+              <a:rPr lang="ru-RU" dirty="0"/>
+              <a:t>Проблема и цель исследования</a:t>
+            </a:r>
           </a:p>
         </p:txBody>
       </p:sp>
@@ -3741,19 +3780,20 @@
         </p:nvSpPr>
         <p:spPr/>
         <p:txBody>
-          <a:bodyPr/>
+          <a:bodyPr>
+            <a:normAutofit/>
+          </a:bodyPr>
           <a:lstStyle/>
           <a:p>
             <a:r>
               <a:rPr lang="ru-RU" dirty="0"/>
-              <a:t>ЭСТОНСКИЙ УНИВЕРСИТЕТ ПРЕДПРИНИМАТЕЛЬСТВА МАЙНОР Учебная программа: Веб-дизайн и цифровая графика Специализация: Веб-технологии Ivan Ireev </a:t>
-            </a:r>
-            <a:endParaRPr lang="en-US" dirty="0"/>
+              <a:t>Проблема: сложность определения наиболее востребованных навыков и инструментов мобильных разработчиков при быстром обновлении технологий.</a:t>
+            </a:r>
           </a:p>
           <a:p>
             <a:r>
               <a:rPr lang="ru-RU" dirty="0"/>
-              <a:t>Анализ частоты упоминаний технологий в вакансиях разработчиков iOS и Android в Европе и Северной Америке Заключительная работа Руководитель: Boris Shvartsman, PhD Таллинн 2025</a:t>
+              <a:t>Цель: выявить наиболее часто упоминаемые в вакансиях технологии для iOS- и Android-разработчиков, сравнить требования в Европе и Северной Америке и составить рекомендации по изучению для специалистов и учебных программ.</a:t>
             </a:r>
           </a:p>
         </p:txBody>
@@ -3762,6 +3802,338 @@
     <p:extLst>
       <p:ext uri="{BB962C8B-B14F-4D97-AF65-F5344CB8AC3E}">
         <p14:creationId xmlns:p14="http://schemas.microsoft.com/office/powerpoint/2010/main" val="3048753171"/>
+      </p:ext>
+    </p:extLst>
+  </p:cSld>
+  <p:clrMapOvr>
+    <a:masterClrMapping/>
+  </p:clrMapOvr>
+</p:sld>
+</file>
+
+<file path=ppt/slides/slide4.xml><?xml version="1.0" encoding="utf-8"?>
+<p:sld xmlns:a="http://schemas.openxmlformats.org/drawingml/2006/main" xmlns:r="http://schemas.openxmlformats.org/officeDocument/2006/relationships" xmlns:p="http://schemas.openxmlformats.org/presentationml/2006/main">
+  <p:cSld>
+    <p:spTree>
+      <p:nvGrpSpPr>
+        <p:cNvPr id="1" name=""/>
+        <p:cNvGrpSpPr/>
+        <p:nvPr/>
+      </p:nvGrpSpPr>
+      <p:grpSpPr>
+        <a:xfrm>
+          <a:off x="0" y="0"/>
+          <a:ext cx="0" cy="0"/>
+          <a:chOff x="0" y="0"/>
+          <a:chExt cx="0" cy="0"/>
+        </a:xfrm>
+      </p:grpSpPr>
+      <p:sp>
+        <p:nvSpPr>
+          <p:cNvPr id="2" name="Title 1">
+            <a:extLst>
+              <a:ext uri="{FF2B5EF4-FFF2-40B4-BE49-F238E27FC236}">
+                <a16:creationId xmlns:a16="http://schemas.microsoft.com/office/drawing/2014/main" id="{D310B972-DCD3-164E-D66C-C0A738DBF382}"/>
+              </a:ext>
+            </a:extLst>
+          </p:cNvPr>
+          <p:cNvSpPr>
+            <a:spLocks noGrp="1"/>
+          </p:cNvSpPr>
+          <p:nvPr>
+            <p:ph type="title"/>
+          </p:nvPr>
+        </p:nvSpPr>
+        <p:spPr/>
+        <p:txBody>
+          <a:bodyPr/>
+          <a:lstStyle/>
+          <a:p>
+            <a:r>
+              <a:rPr lang="ru-RU" dirty="0"/>
+              <a:t>Методология</a:t>
+            </a:r>
+          </a:p>
+        </p:txBody>
+      </p:sp>
+      <p:sp>
+        <p:nvSpPr>
+          <p:cNvPr id="3" name="Content Placeholder 2">
+            <a:extLst>
+              <a:ext uri="{FF2B5EF4-FFF2-40B4-BE49-F238E27FC236}">
+                <a16:creationId xmlns:a16="http://schemas.microsoft.com/office/drawing/2014/main" id="{D130A9BD-B04E-9736-B80F-CBF99CC2CAAA}"/>
+              </a:ext>
+            </a:extLst>
+          </p:cNvPr>
+          <p:cNvSpPr>
+            <a:spLocks noGrp="1"/>
+          </p:cNvSpPr>
+          <p:nvPr>
+            <p:ph idx="1"/>
+          </p:nvPr>
+        </p:nvSpPr>
+        <p:spPr/>
+        <p:txBody>
+          <a:bodyPr/>
+          <a:lstStyle/>
+          <a:p>
+            <a:r>
+              <a:rPr lang="ru-RU" dirty="0"/>
+              <a:t>Сделать схемку</a:t>
+            </a:r>
+          </a:p>
+        </p:txBody>
+      </p:sp>
+    </p:spTree>
+    <p:extLst>
+      <p:ext uri="{BB962C8B-B14F-4D97-AF65-F5344CB8AC3E}">
+        <p14:creationId xmlns:p14="http://schemas.microsoft.com/office/powerpoint/2010/main" val="1705616875"/>
+      </p:ext>
+    </p:extLst>
+  </p:cSld>
+  <p:clrMapOvr>
+    <a:masterClrMapping/>
+  </p:clrMapOvr>
+</p:sld>
+</file>
+
+<file path=ppt/slides/slide5.xml><?xml version="1.0" encoding="utf-8"?>
+<p:sld xmlns:a="http://schemas.openxmlformats.org/drawingml/2006/main" xmlns:r="http://schemas.openxmlformats.org/officeDocument/2006/relationships" xmlns:p="http://schemas.openxmlformats.org/presentationml/2006/main">
+  <p:cSld>
+    <p:spTree>
+      <p:nvGrpSpPr>
+        <p:cNvPr id="1" name=""/>
+        <p:cNvGrpSpPr/>
+        <p:nvPr/>
+      </p:nvGrpSpPr>
+      <p:grpSpPr>
+        <a:xfrm>
+          <a:off x="0" y="0"/>
+          <a:ext cx="0" cy="0"/>
+          <a:chOff x="0" y="0"/>
+          <a:chExt cx="0" cy="0"/>
+        </a:xfrm>
+      </p:grpSpPr>
+      <p:sp>
+        <p:nvSpPr>
+          <p:cNvPr id="2" name="Title 1">
+            <a:extLst>
+              <a:ext uri="{FF2B5EF4-FFF2-40B4-BE49-F238E27FC236}">
+                <a16:creationId xmlns:a16="http://schemas.microsoft.com/office/drawing/2014/main" id="{DAF4E5DE-E810-9EC3-D073-6D9687D6AEB4}"/>
+              </a:ext>
+            </a:extLst>
+          </p:cNvPr>
+          <p:cNvSpPr>
+            <a:spLocks noGrp="1"/>
+          </p:cNvSpPr>
+          <p:nvPr>
+            <p:ph type="title"/>
+          </p:nvPr>
+        </p:nvSpPr>
+        <p:spPr/>
+        <p:txBody>
+          <a:bodyPr/>
+          <a:lstStyle/>
+          <a:p>
+            <a:r>
+              <a:rPr lang="ru-RU" dirty="0"/>
+              <a:t>Результаты</a:t>
+            </a:r>
+          </a:p>
+        </p:txBody>
+      </p:sp>
+      <p:sp>
+        <p:nvSpPr>
+          <p:cNvPr id="3" name="Content Placeholder 2">
+            <a:extLst>
+              <a:ext uri="{FF2B5EF4-FFF2-40B4-BE49-F238E27FC236}">
+                <a16:creationId xmlns:a16="http://schemas.microsoft.com/office/drawing/2014/main" id="{FECD2DE2-A1B2-06B3-C893-46EE72DEB445}"/>
+              </a:ext>
+            </a:extLst>
+          </p:cNvPr>
+          <p:cNvSpPr>
+            <a:spLocks noGrp="1"/>
+          </p:cNvSpPr>
+          <p:nvPr>
+            <p:ph idx="1"/>
+          </p:nvPr>
+        </p:nvSpPr>
+        <p:spPr/>
+        <p:txBody>
+          <a:bodyPr/>
+          <a:lstStyle/>
+          <a:p>
+            <a:endParaRPr lang="ru-RU"/>
+          </a:p>
+        </p:txBody>
+      </p:sp>
+    </p:spTree>
+    <p:extLst>
+      <p:ext uri="{BB962C8B-B14F-4D97-AF65-F5344CB8AC3E}">
+        <p14:creationId xmlns:p14="http://schemas.microsoft.com/office/powerpoint/2010/main" val="1895634139"/>
+      </p:ext>
+    </p:extLst>
+  </p:cSld>
+  <p:clrMapOvr>
+    <a:masterClrMapping/>
+  </p:clrMapOvr>
+</p:sld>
+</file>
+
+<file path=ppt/slides/slide6.xml><?xml version="1.0" encoding="utf-8"?>
+<p:sld xmlns:a="http://schemas.openxmlformats.org/drawingml/2006/main" xmlns:r="http://schemas.openxmlformats.org/officeDocument/2006/relationships" xmlns:p="http://schemas.openxmlformats.org/presentationml/2006/main">
+  <p:cSld>
+    <p:spTree>
+      <p:nvGrpSpPr>
+        <p:cNvPr id="1" name=""/>
+        <p:cNvGrpSpPr/>
+        <p:nvPr/>
+      </p:nvGrpSpPr>
+      <p:grpSpPr>
+        <a:xfrm>
+          <a:off x="0" y="0"/>
+          <a:ext cx="0" cy="0"/>
+          <a:chOff x="0" y="0"/>
+          <a:chExt cx="0" cy="0"/>
+        </a:xfrm>
+      </p:grpSpPr>
+      <p:sp>
+        <p:nvSpPr>
+          <p:cNvPr id="2" name="Title 1">
+            <a:extLst>
+              <a:ext uri="{FF2B5EF4-FFF2-40B4-BE49-F238E27FC236}">
+                <a16:creationId xmlns:a16="http://schemas.microsoft.com/office/drawing/2014/main" id="{19499884-ED48-50C9-4165-051E6C2BED78}"/>
+              </a:ext>
+            </a:extLst>
+          </p:cNvPr>
+          <p:cNvSpPr>
+            <a:spLocks noGrp="1"/>
+          </p:cNvSpPr>
+          <p:nvPr>
+            <p:ph type="title"/>
+          </p:nvPr>
+        </p:nvSpPr>
+        <p:spPr/>
+        <p:txBody>
+          <a:bodyPr/>
+          <a:lstStyle/>
+          <a:p>
+            <a:r>
+              <a:rPr lang="ru-RU" dirty="0"/>
+              <a:t>Результаты</a:t>
+            </a:r>
+          </a:p>
+        </p:txBody>
+      </p:sp>
+      <p:sp>
+        <p:nvSpPr>
+          <p:cNvPr id="3" name="Content Placeholder 2">
+            <a:extLst>
+              <a:ext uri="{FF2B5EF4-FFF2-40B4-BE49-F238E27FC236}">
+                <a16:creationId xmlns:a16="http://schemas.microsoft.com/office/drawing/2014/main" id="{073F2D2F-3CBB-3B06-7E11-EE56A7B51577}"/>
+              </a:ext>
+            </a:extLst>
+          </p:cNvPr>
+          <p:cNvSpPr>
+            <a:spLocks noGrp="1"/>
+          </p:cNvSpPr>
+          <p:nvPr>
+            <p:ph idx="1"/>
+          </p:nvPr>
+        </p:nvSpPr>
+        <p:spPr/>
+        <p:txBody>
+          <a:bodyPr/>
+          <a:lstStyle/>
+          <a:p>
+            <a:endParaRPr lang="ru-RU" dirty="0"/>
+          </a:p>
+        </p:txBody>
+      </p:sp>
+    </p:spTree>
+    <p:extLst>
+      <p:ext uri="{BB962C8B-B14F-4D97-AF65-F5344CB8AC3E}">
+        <p14:creationId xmlns:p14="http://schemas.microsoft.com/office/powerpoint/2010/main" val="1655250204"/>
+      </p:ext>
+    </p:extLst>
+  </p:cSld>
+  <p:clrMapOvr>
+    <a:masterClrMapping/>
+  </p:clrMapOvr>
+</p:sld>
+</file>
+
+<file path=ppt/slides/slide7.xml><?xml version="1.0" encoding="utf-8"?>
+<p:sld xmlns:a="http://schemas.openxmlformats.org/drawingml/2006/main" xmlns:r="http://schemas.openxmlformats.org/officeDocument/2006/relationships" xmlns:p="http://schemas.openxmlformats.org/presentationml/2006/main">
+  <p:cSld>
+    <p:spTree>
+      <p:nvGrpSpPr>
+        <p:cNvPr id="1" name=""/>
+        <p:cNvGrpSpPr/>
+        <p:nvPr/>
+      </p:nvGrpSpPr>
+      <p:grpSpPr>
+        <a:xfrm>
+          <a:off x="0" y="0"/>
+          <a:ext cx="0" cy="0"/>
+          <a:chOff x="0" y="0"/>
+          <a:chExt cx="0" cy="0"/>
+        </a:xfrm>
+      </p:grpSpPr>
+      <p:sp>
+        <p:nvSpPr>
+          <p:cNvPr id="2" name="Title 1">
+            <a:extLst>
+              <a:ext uri="{FF2B5EF4-FFF2-40B4-BE49-F238E27FC236}">
+                <a16:creationId xmlns:a16="http://schemas.microsoft.com/office/drawing/2014/main" id="{B6F64BA4-0D1D-0885-752D-4A3101ED7AB7}"/>
+              </a:ext>
+            </a:extLst>
+          </p:cNvPr>
+          <p:cNvSpPr>
+            <a:spLocks noGrp="1"/>
+          </p:cNvSpPr>
+          <p:nvPr>
+            <p:ph type="title"/>
+          </p:nvPr>
+        </p:nvSpPr>
+        <p:spPr/>
+        <p:txBody>
+          <a:bodyPr/>
+          <a:lstStyle/>
+          <a:p>
+            <a:endParaRPr lang="ru-RU"/>
+          </a:p>
+        </p:txBody>
+      </p:sp>
+      <p:sp>
+        <p:nvSpPr>
+          <p:cNvPr id="3" name="Content Placeholder 2">
+            <a:extLst>
+              <a:ext uri="{FF2B5EF4-FFF2-40B4-BE49-F238E27FC236}">
+                <a16:creationId xmlns:a16="http://schemas.microsoft.com/office/drawing/2014/main" id="{22CE1CD7-22EA-5A23-350B-EF2A5E77A4EC}"/>
+              </a:ext>
+            </a:extLst>
+          </p:cNvPr>
+          <p:cNvSpPr>
+            <a:spLocks noGrp="1"/>
+          </p:cNvSpPr>
+          <p:nvPr>
+            <p:ph idx="1"/>
+          </p:nvPr>
+        </p:nvSpPr>
+        <p:spPr/>
+        <p:txBody>
+          <a:bodyPr/>
+          <a:lstStyle/>
+          <a:p>
+            <a:endParaRPr lang="ru-RU"/>
+          </a:p>
+        </p:txBody>
+      </p:sp>
+    </p:spTree>
+    <p:extLst>
+      <p:ext uri="{BB962C8B-B14F-4D97-AF65-F5344CB8AC3E}">
+        <p14:creationId xmlns:p14="http://schemas.microsoft.com/office/powerpoint/2010/main" val="1316099249"/>
       </p:ext>
     </p:extLst>
   </p:cSld>

</xml_diff>